<commit_message>
Defense slides: ten respondents, 4.59, every characteristic Very High Quality
Slides 16 to 18 carried the six-respondent scores (4.53). They now carry
Table 4-17 in rank order, slide 17 says measured and rated evidence agree
on all eight (Section 4.4.5), and slide 15 says the 24 of 25 are the
walkthrough steps the owner performed.

Co-Authored-By: Claude Opus 5.5 <noreply@anthropic.com>
</commit_message>
<xml_diff>
--- a/FINAL/HIVELET DEFENSE SLIDES.pptx
+++ b/FINAL/HIVELET DEFENSE SLIDES.pptx
@@ -199,10 +199,10 @@
                     <c:v>Security</c:v>
                   </c:pt>
                   <c:pt idx="3">
-                    <c:v>Compatibility</c:v>
+                    <c:v>Reliability</c:v>
                   </c:pt>
                   <c:pt idx="4">
-                    <c:v>Reliability</c:v>
+                    <c:v>Compatibility</c:v>
                   </c:pt>
                   <c:pt idx="5">
                     <c:v>Performance Efficiency</c:v>
@@ -224,28 +224,28 @@
                 <c:formatCode>General</c:formatCode>
                 <c:ptCount val="8"/>
                 <c:pt idx="0">
-                  <c:v>4.89</c:v>
+                  <c:v>4.86</c:v>
                 </c:pt>
                 <c:pt idx="1">
-                  <c:v>4.86</c:v>
+                  <c:v>4.79</c:v>
                 </c:pt>
                 <c:pt idx="2">
-                  <c:v>4.7</c:v>
+                  <c:v>4.68</c:v>
                 </c:pt>
                 <c:pt idx="3">
-                  <c:v>4.67</c:v>
+                  <c:v>4.61</c:v>
                 </c:pt>
                 <c:pt idx="4">
-                  <c:v>4.62</c:v>
+                  <c:v>4.55</c:v>
                 </c:pt>
                 <c:pt idx="5">
+                  <c:v>4.48</c:v>
+                </c:pt>
+                <c:pt idx="6">
                   <c:v>4.42</c:v>
                 </c:pt>
-                <c:pt idx="6">
-                  <c:v>4.12</c:v>
-                </c:pt>
                 <c:pt idx="7">
-                  <c:v>4</c:v>
+                  <c:v>4.32</c:v>
                 </c:pt>
               </c:numCache>
             </c:numRef>
@@ -1409,7 +1409,7 @@
           <a:p>
             <a:r>
               <a:rPr lang="en-US" dirty="0"/>
-              <a:t>Composite means (Table 4-17), mean of the group means. Six respondents: the owner, three tenants, a prospective tenant and a technical evaluator. Every characteristic at least High Quality.</a:t>
+              <a:t>Composite means (Table 4-17), mean of the group means. Ten respondents: the owner, three tenants, a prospective tenant and five technical evaluators. Every characteristic Very High Quality.</a:t>
             </a:r>
             <a:endParaRPr lang="en-US" dirty="0"/>
           </a:p>
@@ -1497,7 +1497,7 @@
           <a:p>
             <a:r>
               <a:rPr lang="en-US" dirty="0"/>
-              <a:t>Usability is the exception: the measures pass, but the owner rated learning without help lower. Maintainability rests on the measurements from the code more than on the one rating (Section 4.4.5).</a:t>
+              <a:t>Usability agrees once the later technical evaluators had rated it. The owner's two 3s still mark where a first-time user needs help (Section 4.4.5).</a:t>
             </a:r>
             <a:endParaRPr lang="en-US" dirty="0"/>
           </a:p>
@@ -6457,7 +6457,7 @@
                 <a:ea typeface="Arial" pitchFamily="34" charset="-122"/>
                 <a:cs typeface="Arial" pitchFamily="34" charset="-120"/>
               </a:rPr>
-              <a:t>owner's walkthrough steps passed</a:t>
+              <a:t>walkthrough steps the owner performed passed the first time</a:t>
             </a:r>
             <a:endParaRPr lang="en-US" sz="1300" dirty="0"/>
           </a:p>
@@ -6608,7 +6608,7 @@
                 <a:ea typeface="Arial" pitchFamily="34" charset="-122"/>
                 <a:cs typeface="Arial" pitchFamily="34" charset="-120"/>
               </a:rPr>
-              <a:t>ISO/IEC 25010 evaluation: 4.53, Very High Quality</a:t>
+              <a:t>ISO/IEC 25010 evaluation: 4.59, Very High Quality</a:t>
             </a:r>
             <a:endParaRPr lang="en-US" sz="2800" dirty="0"/>
           </a:p>
@@ -6736,7 +6736,7 @@
                 <a:ea typeface="Arial" pitchFamily="34" charset="-122"/>
                 <a:cs typeface="Arial" pitchFamily="34" charset="-120"/>
               </a:rPr>
-              <a:t>Measured and rated evidence agree on seven of eight</a:t>
+              <a:t>Measured and rated evidence agree on all eight</a:t>
             </a:r>
             <a:endParaRPr lang="en-US" sz="2800" dirty="0"/>
           </a:p>
@@ -6800,7 +6800,7 @@
                 <a:ea typeface="Arial" pitchFamily="34" charset="-122"/>
                 <a:cs typeface="Arial" pitchFamily="34" charset="-120"/>
               </a:rPr>
-              <a:t>Usability (4.12): every task done, but learning without help rated lower</a:t>
+              <a:t>Usability (4.42): nine tasks in ten done without help; the owner rated learning without help lower</a:t>
             </a:r>
             <a:endParaRPr lang="en-US" sz="2100" dirty="0"/>
           </a:p>
@@ -6821,7 +6821,7 @@
                 <a:ea typeface="Arial" pitchFamily="34" charset="-122"/>
                 <a:cs typeface="Arial" pitchFamily="34" charset="-120"/>
               </a:rPr>
-              <a:t>Maintainability (4.00): checks pass on every change, but three database calls in four sit inside the request handlers</a:t>
+              <a:t>Maintainability (4.32): checks pass on every change, but three database calls in four sit inside the request handlers</a:t>
             </a:r>
             <a:endParaRPr lang="en-US" sz="2100" dirty="0"/>
           </a:p>
@@ -6842,7 +6842,7 @@
                 <a:ea typeface="Arial" pitchFamily="34" charset="-122"/>
                 <a:cs typeface="Arial" pitchFamily="34" charset="-120"/>
               </a:rPr>
-              <a:t>The 14 comments of the technical evaluator were all acted on by 5 October</a:t>
+              <a:t>The 14 comments of 3 October were all acted on by 5 October</a:t>
             </a:r>
             <a:endParaRPr lang="en-US" sz="2100" dirty="0"/>
           </a:p>
@@ -7407,7 +7407,7 @@
                 <a:ea typeface="Arial" pitchFamily="34" charset="-122"/>
                 <a:cs typeface="Arial" pitchFamily="34" charset="-120"/>
               </a:rPr>
-              <a:t>Very High Quality overall (4.53) on ISO/IEC 25010; 51 optimizations made</a:t>
+              <a:t>Very High Quality overall (4.59) on ISO/IEC 25010; 51 optimizations made</a:t>
             </a:r>
             <a:endParaRPr lang="en-US" sz="1900" dirty="0"/>
           </a:p>

</xml_diff>